<commit_message>
Presentation: visual and storytelling upgrade (same 22-slide storyline)
- Real data as the hero: the title and problem slides draw one participant's
  real native CGM trace; product slides use new screenshots at a real
  high-risk meal (75% estimated, 204 mg/dL measured peak)
- Redesigned problem, gap, concept, dataset, pipeline, leakage, results,
  architecture, product, explainability, what-if, replay, security, stack,
  outcome, limitations, future and demo slides
- What-if shows the real model output (66 -> 46 g carbs: 75% -> 57%,
  -17.9 pp); replay shows real Twin states t0-t3
- PPTX gets a quiet fade between slides

All numbers from data/reports, the test runs, or the real local stack.

Co-Authored-By: Claude Opus 5.5 (1M context) <noreply@anthropic.com>
</commit_message>
<xml_diff>
--- a/IdeaForge_IIIT_ALLAHABAD/Presentation.pptx
+++ b/IdeaForge_IIIT_ALLAHABAD/Presentation.pptx
@@ -130,6 +130,9 @@
   <p:clrMapOvr>
     <a:masterClrMapping/>
   </p:clrMapOvr>
+  <p:transition spd="med">
+    <p:fade/>
+  </p:transition>
 </p:sld>
 </file>
 
@@ -179,6 +182,9 @@
   <p:clrMapOvr>
     <a:masterClrMapping/>
   </p:clrMapOvr>
+  <p:transition spd="med">
+    <p:fade/>
+  </p:transition>
 </p:sld>
 </file>
 
@@ -228,6 +234,9 @@
   <p:clrMapOvr>
     <a:masterClrMapping/>
   </p:clrMapOvr>
+  <p:transition spd="med">
+    <p:fade/>
+  </p:transition>
 </p:sld>
 </file>
 
@@ -277,6 +286,9 @@
   <p:clrMapOvr>
     <a:masterClrMapping/>
   </p:clrMapOvr>
+  <p:transition spd="med">
+    <p:fade/>
+  </p:transition>
 </p:sld>
 </file>
 
@@ -326,6 +338,9 @@
   <p:clrMapOvr>
     <a:masterClrMapping/>
   </p:clrMapOvr>
+  <p:transition spd="med">
+    <p:fade/>
+  </p:transition>
 </p:sld>
 </file>
 
@@ -375,6 +390,9 @@
   <p:clrMapOvr>
     <a:masterClrMapping/>
   </p:clrMapOvr>
+  <p:transition spd="med">
+    <p:fade/>
+  </p:transition>
 </p:sld>
 </file>
 
@@ -424,6 +442,9 @@
   <p:clrMapOvr>
     <a:masterClrMapping/>
   </p:clrMapOvr>
+  <p:transition spd="med">
+    <p:fade/>
+  </p:transition>
 </p:sld>
 </file>
 
@@ -473,6 +494,9 @@
   <p:clrMapOvr>
     <a:masterClrMapping/>
   </p:clrMapOvr>
+  <p:transition spd="med">
+    <p:fade/>
+  </p:transition>
 </p:sld>
 </file>
 
@@ -522,6 +546,9 @@
   <p:clrMapOvr>
     <a:masterClrMapping/>
   </p:clrMapOvr>
+  <p:transition spd="med">
+    <p:fade/>
+  </p:transition>
 </p:sld>
 </file>
 
@@ -571,6 +598,9 @@
   <p:clrMapOvr>
     <a:masterClrMapping/>
   </p:clrMapOvr>
+  <p:transition spd="med">
+    <p:fade/>
+  </p:transition>
 </p:sld>
 </file>
 
@@ -620,6 +650,9 @@
   <p:clrMapOvr>
     <a:masterClrMapping/>
   </p:clrMapOvr>
+  <p:transition spd="med">
+    <p:fade/>
+  </p:transition>
 </p:sld>
 </file>
 
@@ -669,6 +702,9 @@
   <p:clrMapOvr>
     <a:masterClrMapping/>
   </p:clrMapOvr>
+  <p:transition spd="med">
+    <p:fade/>
+  </p:transition>
 </p:sld>
 </file>
 
@@ -718,6 +754,9 @@
   <p:clrMapOvr>
     <a:masterClrMapping/>
   </p:clrMapOvr>
+  <p:transition spd="med">
+    <p:fade/>
+  </p:transition>
 </p:sld>
 </file>
 
@@ -767,6 +806,9 @@
   <p:clrMapOvr>
     <a:masterClrMapping/>
   </p:clrMapOvr>
+  <p:transition spd="med">
+    <p:fade/>
+  </p:transition>
 </p:sld>
 </file>
 
@@ -816,6 +858,9 @@
   <p:clrMapOvr>
     <a:masterClrMapping/>
   </p:clrMapOvr>
+  <p:transition spd="med">
+    <p:fade/>
+  </p:transition>
 </p:sld>
 </file>
 
@@ -865,6 +910,9 @@
   <p:clrMapOvr>
     <a:masterClrMapping/>
   </p:clrMapOvr>
+  <p:transition spd="med">
+    <p:fade/>
+  </p:transition>
 </p:sld>
 </file>
 
@@ -914,6 +962,9 @@
   <p:clrMapOvr>
     <a:masterClrMapping/>
   </p:clrMapOvr>
+  <p:transition spd="med">
+    <p:fade/>
+  </p:transition>
 </p:sld>
 </file>
 
@@ -963,6 +1014,9 @@
   <p:clrMapOvr>
     <a:masterClrMapping/>
   </p:clrMapOvr>
+  <p:transition spd="med">
+    <p:fade/>
+  </p:transition>
 </p:sld>
 </file>
 
@@ -1012,6 +1066,9 @@
   <p:clrMapOvr>
     <a:masterClrMapping/>
   </p:clrMapOvr>
+  <p:transition spd="med">
+    <p:fade/>
+  </p:transition>
 </p:sld>
 </file>
 
@@ -1061,6 +1118,9 @@
   <p:clrMapOvr>
     <a:masterClrMapping/>
   </p:clrMapOvr>
+  <p:transition spd="med">
+    <p:fade/>
+  </p:transition>
 </p:sld>
 </file>
 
@@ -1110,6 +1170,9 @@
   <p:clrMapOvr>
     <a:masterClrMapping/>
   </p:clrMapOvr>
+  <p:transition spd="med">
+    <p:fade/>
+  </p:transition>
 </p:sld>
 </file>
 
@@ -1159,6 +1222,9 @@
   <p:clrMapOvr>
     <a:masterClrMapping/>
   </p:clrMapOvr>
+  <p:transition spd="med">
+    <p:fade/>
+  </p:transition>
 </p:sld>
 </file>
 

</xml_diff>